<commit_message>
fix(docs): docx according  "ГОСТ", add presentation datapreparing slide
</commit_message>
<xml_diff>
--- a/docs/presentation/Rhymer_presentation_final.pptx
+++ b/docs/presentation/Rhymer_presentation_final.pptx
@@ -24,6 +24,7 @@
     <p:sldId id="262" r:id="rId19"/>
     <p:sldId id="263" r:id="rId20"/>
     <p:sldId id="264" r:id="rId21"/>
+    <p:sldId id="277" r:id="rId35"/>
     <p:sldId id="265" r:id="rId22"/>
     <p:sldId id="266" r:id="rId23"/>
     <p:sldId id="267" r:id="rId24"/>
@@ -8919,7 +8920,7 @@
                 <a:latin typeface="Bungee"/>
                 <a:ea typeface="Bungee"/>
               </a:rPr>
-              <a:t>Авторский алгоритм: идея – рифмы – есть затухание слоговых волн</a:t>
+              <a:t>Авторский алгоритм: рифма как затухание слоговых волн (потенциал Юкавы)</a:t>
             </a:r>
             <a:endParaRPr b="0" lang="en-US" sz="2600" spc="-1" strike="noStrike">
               <a:solidFill>
@@ -16832,6 +16833,1704 @@
   <p:transition>
     <p:push dir="r"/>
   </p:transition>
+</p:sld>
+</file>
+
+<file path=ppt/slides/slide22.xml><?xml version="1.0" encoding="utf-8"?>
+<p:sld xmlns:a="http://schemas.openxmlformats.org/drawingml/2006/main" xmlns:p="http://schemas.openxmlformats.org/presentationml/2006/main" xmlns:r="http://schemas.openxmlformats.org/officeDocument/2006/relationships">
+  <p:cSld>
+    <p:bg>
+      <p:bgPr>
+        <a:solidFill>
+          <a:srgbClr val="7536ff"/>
+        </a:solidFill>
+      </p:bgPr>
+    </p:bg>
+    <p:spTree>
+      <p:nvGrpSpPr>
+        <p:cNvPr id="1" name=""/>
+        <p:cNvGrpSpPr/>
+        <p:nvPr/>
+      </p:nvGrpSpPr>
+      <p:grpSpPr/>
+      <p:sp>
+        <p:nvSpPr>
+          <p:cNvPr id="334" name="Google Shape;436;p24"/>
+          <p:cNvSpPr/>
+          <p:nvPr/>
+        </p:nvSpPr>
+        <p:spPr>
+          <a:xfrm>
+            <a:off x="-1286640" y="-7313400"/>
+            <a:ext cx="25325280" cy="17790480"/>
+          </a:xfrm>
+          <a:custGeom>
+            <a:avLst/>
+            <a:gdLst>
+              <a:gd name="textAreaLeft" fmla="*/ 0 w 25325280"/>
+              <a:gd name="textAreaRight" fmla="*/ 25327080 w 25325280"/>
+              <a:gd name="textAreaTop" fmla="*/ 0 h 17790480"/>
+              <a:gd name="textAreaBottom" fmla="*/ 17792280 h 17790480"/>
+            </a:gdLst>
+            <a:ahLst/>
+            <a:rect l="textAreaLeft" t="textAreaTop" r="textAreaRight" b="textAreaBottom"/>
+            <a:pathLst>
+              <a:path w="25327108" h="17792293">
+                <a:moveTo>
+                  <a:pt x="0" y="0"/>
+                </a:moveTo>
+                <a:lnTo>
+                  <a:pt x="25327108" y="0"/>
+                </a:lnTo>
+                <a:lnTo>
+                  <a:pt x="25327108" y="17792293"/>
+                </a:lnTo>
+                <a:lnTo>
+                  <a:pt x="0" y="17792293"/>
+                </a:lnTo>
+                <a:lnTo>
+                  <a:pt x="0" y="0"/>
+                </a:lnTo>
+                <a:close/>
+              </a:path>
+            </a:pathLst>
+          </a:custGeom>
+          <a:blipFill rotWithShape="0">
+            <a:blip r:embed="rId2"/>
+            <a:srcRect/>
+            <a:stretch/>
+          </a:blipFill>
+          <a:ln w="0">
+            <a:noFill/>
+          </a:ln>
+        </p:spPr>
+        <p:style>
+          <a:lnRef idx="0"/>
+          <a:fillRef idx="0"/>
+          <a:effectRef idx="0"/>
+          <a:fontRef idx="minor"/>
+        </p:style>
+        <p:txBody>
+          <a:bodyPr lIns="90000" rIns="90000" tIns="45000" bIns="45000" anchor="t">
+            <a:noAutofit/>
+          </a:bodyPr>
+          <a:p>
+            <a:pPr>
+              <a:lnSpc>
+                <a:spcPct val="100000"/>
+              </a:lnSpc>
+            </a:pPr>
+            <a:endParaRPr b="0" lang="en-US" sz="1800" spc="-1" strike="noStrike">
+              <a:solidFill>
+                <a:srgbClr val="000000"/>
+              </a:solidFill>
+              <a:latin typeface="Arial"/>
+            </a:endParaRPr>
+          </a:p>
+        </p:txBody>
+      </p:sp>
+      <p:graphicFrame>
+        <p:nvGraphicFramePr>
+          <p:cNvPr id="335" name="Google Shape;437;p24"/>
+          <p:cNvGraphicFramePr/>
+          <p:nvPr/>
+        </p:nvGraphicFramePr>
+        <p:xfrm>
+          <a:off x="393840" y="1262160"/>
+          <a:ext cx="3974760" cy="8091000"/>
+        </p:xfrm>
+        <a:graphic>
+          <a:graphicData uri="http://schemas.openxmlformats.org/drawingml/2006/table">
+            <a:tbl>
+              <a:tblPr/>
+              <a:tblGrid>
+                <a:gridCol w="3975120"/>
+              </a:tblGrid>
+              <a:tr h="1071720">
+                <a:tc>
+                  <a:txBody>
+                    <a:bodyPr lIns="190440" rIns="190440" anchor="ctr">
+                      <a:noAutofit/>
+                    </a:bodyPr>
+                    <a:p>
+                      <a:pPr algn="ctr">
+                        <a:lnSpc>
+                          <a:spcPct val="140000"/>
+                        </a:lnSpc>
+                        <a:tabLst>
+                          <a:tab algn="l" pos="0"/>
+                        </a:tabLst>
+                      </a:pPr>
+                      <a:r>
+                        <a:rPr b="1" lang="en-US" sz="3200" spc="-1" strike="noStrike">
+                          <a:solidFill>
+                            <a:srgbClr val="ffffff"/>
+                          </a:solidFill>
+                          <a:latin typeface="Lato"/>
+                          <a:ea typeface="Lato"/>
+                        </a:rPr>
+                        <a:t>1</a:t>
+                      </a:r>
+                      <a:endParaRPr b="0" lang="en-US" sz="3200" spc="-1" strike="noStrike">
+                        <a:solidFill>
+                          <a:srgbClr val="ffffff"/>
+                        </a:solidFill>
+                        <a:latin typeface="Arial"/>
+                      </a:endParaRPr>
+                    </a:p>
+                  </a:txBody>
+                  <a:tcPr anchor="ctr" marL="190440" marR="190440">
+                    <a:lnL w="38160">
+                      <a:solidFill>
+                        <a:srgbClr val="000000"/>
+                      </a:solidFill>
+                      <a:prstDash val="solid"/>
+                    </a:lnL>
+                    <a:lnR w="38160">
+                      <a:solidFill>
+                        <a:srgbClr val="000000"/>
+                      </a:solidFill>
+                      <a:prstDash val="solid"/>
+                    </a:lnR>
+                    <a:lnT w="38160">
+                      <a:solidFill>
+                        <a:srgbClr val="000000"/>
+                      </a:solidFill>
+                      <a:prstDash val="solid"/>
+                    </a:lnT>
+                    <a:lnB w="38160">
+                      <a:solidFill>
+                        <a:srgbClr val="000000"/>
+                      </a:solidFill>
+                      <a:prstDash val="solid"/>
+                    </a:lnB>
+                    <a:solidFill>
+                      <a:srgbClr val="b35eff"/>
+                    </a:solidFill>
+                  </a:tcPr>
+                </a:tc>
+              </a:tr>
+              <a:tr h="1071720">
+                <a:tc>
+                  <a:txBody>
+                    <a:bodyPr lIns="190440" rIns="190440" anchor="ctr">
+                      <a:noAutofit/>
+                    </a:bodyPr>
+                    <a:p>
+                      <a:pPr algn="ctr">
+                        <a:lnSpc>
+                          <a:spcPct val="140000"/>
+                        </a:lnSpc>
+                        <a:tabLst>
+                          <a:tab algn="l" pos="0"/>
+                        </a:tabLst>
+                      </a:pPr>
+                      <a:r>
+                        <a:rPr b="1" lang="en-US" sz="3200" spc="-1" strike="noStrike">
+                          <a:solidFill>
+                            <a:srgbClr val="000000"/>
+                          </a:solidFill>
+                          <a:latin typeface="Lato"/>
+                          <a:ea typeface="Lato"/>
+                        </a:rPr>
+                        <a:t>Токенизация</a:t>
+                      </a:r>
+                      <a:endParaRPr b="0" lang="en-US" sz="3200" spc="-1" strike="noStrike">
+                        <a:solidFill>
+                          <a:srgbClr val="000000"/>
+                        </a:solidFill>
+                        <a:latin typeface="Arial"/>
+                      </a:endParaRPr>
+                    </a:p>
+                  </a:txBody>
+                  <a:tcPr anchor="ctr" marL="190440" marR="190440">
+                    <a:lnL w="38160">
+                      <a:solidFill>
+                        <a:srgbClr val="000000"/>
+                      </a:solidFill>
+                      <a:prstDash val="solid"/>
+                    </a:lnL>
+                    <a:lnR w="38160">
+                      <a:solidFill>
+                        <a:srgbClr val="000000"/>
+                      </a:solidFill>
+                      <a:prstDash val="solid"/>
+                    </a:lnR>
+                    <a:lnT w="38160">
+                      <a:solidFill>
+                        <a:srgbClr val="000000"/>
+                      </a:solidFill>
+                      <a:prstDash val="solid"/>
+                    </a:lnT>
+                    <a:lnB w="38160">
+                      <a:solidFill>
+                        <a:srgbClr val="000000"/>
+                      </a:solidFill>
+                      <a:prstDash val="solid"/>
+                    </a:lnB>
+                    <a:solidFill>
+                      <a:srgbClr val="ffffff"/>
+                    </a:solidFill>
+                  </a:tcPr>
+                </a:tc>
+              </a:tr>
+              <a:tr h="5947560">
+                <a:tc>
+                  <a:txBody>
+                    <a:bodyPr lIns="190440" rIns="190440" anchor="ctr">
+                      <a:noAutofit/>
+                    </a:bodyPr>
+                    <a:p>
+                      <a:endParaRPr b="0" lang="en-US" sz="1800" spc="-1" strike="noStrike">
+                        <a:solidFill>
+                          <a:srgbClr val="000000"/>
+                        </a:solidFill>
+                        <a:latin typeface="Arial"/>
+                      </a:endParaRPr>
+                    </a:p>
+                  </a:txBody>
+                  <a:tcPr anchor="ctr" marL="190440" marR="190440">
+                    <a:lnL w="38160">
+                      <a:solidFill>
+                        <a:srgbClr val="000000"/>
+                      </a:solidFill>
+                      <a:prstDash val="solid"/>
+                    </a:lnL>
+                    <a:lnR w="38160">
+                      <a:solidFill>
+                        <a:srgbClr val="000000"/>
+                      </a:solidFill>
+                      <a:prstDash val="solid"/>
+                    </a:lnR>
+                    <a:lnT w="38160">
+                      <a:solidFill>
+                        <a:srgbClr val="000000"/>
+                      </a:solidFill>
+                      <a:prstDash val="solid"/>
+                    </a:lnT>
+                    <a:lnB w="38160">
+                      <a:solidFill>
+                        <a:srgbClr val="000000"/>
+                      </a:solidFill>
+                      <a:prstDash val="solid"/>
+                    </a:lnB>
+                    <a:solidFill>
+                      <a:srgbClr val="ffffff"/>
+                    </a:solidFill>
+                  </a:tcPr>
+                </a:tc>
+              </a:tr>
+            </a:tbl>
+          </a:graphicData>
+        </a:graphic>
+      </p:graphicFrame>
+      <p:graphicFrame>
+        <p:nvGraphicFramePr>
+          <p:cNvPr id="336" name="Google Shape;438;p24"/>
+          <p:cNvGraphicFramePr/>
+          <p:nvPr/>
+        </p:nvGraphicFramePr>
+        <p:xfrm>
+          <a:off x="4860000" y="1262160"/>
+          <a:ext cx="3974760" cy="8091000"/>
+        </p:xfrm>
+        <a:graphic>
+          <a:graphicData uri="http://schemas.openxmlformats.org/drawingml/2006/table">
+            <a:tbl>
+              <a:tblPr/>
+              <a:tblGrid>
+                <a:gridCol w="3975120"/>
+              </a:tblGrid>
+              <a:tr h="1071720">
+                <a:tc>
+                  <a:txBody>
+                    <a:bodyPr lIns="190440" rIns="190440" anchor="ctr">
+                      <a:noAutofit/>
+                    </a:bodyPr>
+                    <a:p>
+                      <a:pPr algn="ctr">
+                        <a:lnSpc>
+                          <a:spcPct val="140000"/>
+                        </a:lnSpc>
+                        <a:tabLst>
+                          <a:tab algn="l" pos="0"/>
+                        </a:tabLst>
+                      </a:pPr>
+                      <a:r>
+                        <a:rPr b="1" lang="en-US" sz="3200" spc="-1" strike="noStrike">
+                          <a:solidFill>
+                            <a:srgbClr val="ffffff"/>
+                          </a:solidFill>
+                          <a:latin typeface="Lato"/>
+                          <a:ea typeface="Lato"/>
+                        </a:rPr>
+                        <a:t>2</a:t>
+                      </a:r>
+                      <a:endParaRPr b="0" lang="en-US" sz="3200" spc="-1" strike="noStrike">
+                        <a:solidFill>
+                          <a:srgbClr val="ffffff"/>
+                        </a:solidFill>
+                        <a:latin typeface="Arial"/>
+                      </a:endParaRPr>
+                    </a:p>
+                  </a:txBody>
+                  <a:tcPr anchor="ctr" marL="190440" marR="190440">
+                    <a:lnL w="38160">
+                      <a:solidFill>
+                        <a:srgbClr val="000000"/>
+                      </a:solidFill>
+                      <a:prstDash val="solid"/>
+                    </a:lnL>
+                    <a:lnR w="38160">
+                      <a:solidFill>
+                        <a:srgbClr val="000000"/>
+                      </a:solidFill>
+                      <a:prstDash val="solid"/>
+                    </a:lnR>
+                    <a:lnT w="38160">
+                      <a:solidFill>
+                        <a:srgbClr val="000000"/>
+                      </a:solidFill>
+                      <a:prstDash val="solid"/>
+                    </a:lnT>
+                    <a:lnB w="38160">
+                      <a:solidFill>
+                        <a:srgbClr val="000000"/>
+                      </a:solidFill>
+                      <a:prstDash val="solid"/>
+                    </a:lnB>
+                    <a:solidFill>
+                      <a:srgbClr val="e30350"/>
+                    </a:solidFill>
+                  </a:tcPr>
+                </a:tc>
+              </a:tr>
+              <a:tr h="1071720">
+                <a:tc>
+                  <a:txBody>
+                    <a:bodyPr lIns="190440" rIns="190440" anchor="ctr">
+                      <a:noAutofit/>
+                    </a:bodyPr>
+                    <a:p>
+                      <a:pPr algn="ctr">
+                        <a:lnSpc>
+                          <a:spcPct val="140000"/>
+                        </a:lnSpc>
+                        <a:tabLst>
+                          <a:tab algn="l" pos="0"/>
+                        </a:tabLst>
+                      </a:pPr>
+                      <a:r>
+                        <a:rPr b="1" lang="en-US" sz="2800" spc="-1" strike="noStrike">
+                          <a:solidFill>
+                            <a:srgbClr val="000000"/>
+                          </a:solidFill>
+                          <a:latin typeface="Lato"/>
+                          <a:ea typeface="Lato"/>
+                        </a:rPr>
+                        <a:t>Нормализация</a:t>
+                      </a:r>
+                      <a:endParaRPr b="0" lang="en-US" sz="2800" spc="-1" strike="noStrike">
+                        <a:solidFill>
+                          <a:srgbClr val="000000"/>
+                        </a:solidFill>
+                        <a:latin typeface="Arial"/>
+                      </a:endParaRPr>
+                    </a:p>
+                  </a:txBody>
+                  <a:tcPr anchor="ctr" marL="190440" marR="190440">
+                    <a:lnL w="38160">
+                      <a:solidFill>
+                        <a:srgbClr val="000000"/>
+                      </a:solidFill>
+                      <a:prstDash val="solid"/>
+                    </a:lnL>
+                    <a:lnR w="38160">
+                      <a:solidFill>
+                        <a:srgbClr val="000000"/>
+                      </a:solidFill>
+                      <a:prstDash val="solid"/>
+                    </a:lnR>
+                    <a:lnT w="38160">
+                      <a:solidFill>
+                        <a:srgbClr val="000000"/>
+                      </a:solidFill>
+                      <a:prstDash val="solid"/>
+                    </a:lnT>
+                    <a:lnB w="38160">
+                      <a:solidFill>
+                        <a:srgbClr val="000000"/>
+                      </a:solidFill>
+                      <a:prstDash val="solid"/>
+                    </a:lnB>
+                    <a:solidFill>
+                      <a:srgbClr val="ffffff"/>
+                    </a:solidFill>
+                  </a:tcPr>
+                </a:tc>
+              </a:tr>
+              <a:tr h="5947560">
+                <a:tc>
+                  <a:txBody>
+                    <a:bodyPr lIns="190440" rIns="190440" anchor="ctr">
+                      <a:noAutofit/>
+                    </a:bodyPr>
+                    <a:p>
+                      <a:endParaRPr b="0" lang="en-US" sz="1800" spc="-1" strike="noStrike">
+                        <a:solidFill>
+                          <a:srgbClr val="000000"/>
+                        </a:solidFill>
+                        <a:latin typeface="Arial"/>
+                      </a:endParaRPr>
+                    </a:p>
+                  </a:txBody>
+                  <a:tcPr anchor="ctr" marL="190440" marR="190440">
+                    <a:lnL w="38160">
+                      <a:solidFill>
+                        <a:srgbClr val="000000"/>
+                      </a:solidFill>
+                      <a:prstDash val="solid"/>
+                    </a:lnL>
+                    <a:lnR w="38160">
+                      <a:solidFill>
+                        <a:srgbClr val="000000"/>
+                      </a:solidFill>
+                      <a:prstDash val="solid"/>
+                    </a:lnR>
+                    <a:lnT w="38160">
+                      <a:solidFill>
+                        <a:srgbClr val="000000"/>
+                      </a:solidFill>
+                      <a:prstDash val="solid"/>
+                    </a:lnT>
+                    <a:lnB w="38160">
+                      <a:solidFill>
+                        <a:srgbClr val="000000"/>
+                      </a:solidFill>
+                      <a:prstDash val="solid"/>
+                    </a:lnB>
+                    <a:solidFill>
+                      <a:srgbClr val="ffffff"/>
+                    </a:solidFill>
+                  </a:tcPr>
+                </a:tc>
+              </a:tr>
+            </a:tbl>
+          </a:graphicData>
+        </a:graphic>
+      </p:graphicFrame>
+      <p:graphicFrame>
+        <p:nvGraphicFramePr>
+          <p:cNvPr id="337" name="Google Shape;439;p24"/>
+          <p:cNvGraphicFramePr/>
+          <p:nvPr/>
+        </p:nvGraphicFramePr>
+        <p:xfrm>
+          <a:off x="9326160" y="1262160"/>
+          <a:ext cx="3974760" cy="8091000"/>
+        </p:xfrm>
+        <a:graphic>
+          <a:graphicData uri="http://schemas.openxmlformats.org/drawingml/2006/table">
+            <a:tbl>
+              <a:tblPr/>
+              <a:tblGrid>
+                <a:gridCol w="3975120"/>
+              </a:tblGrid>
+              <a:tr h="1071720">
+                <a:tc>
+                  <a:txBody>
+                    <a:bodyPr lIns="190440" rIns="190440" anchor="ctr">
+                      <a:noAutofit/>
+                    </a:bodyPr>
+                    <a:p>
+                      <a:pPr algn="ctr">
+                        <a:lnSpc>
+                          <a:spcPct val="140000"/>
+                        </a:lnSpc>
+                        <a:tabLst>
+                          <a:tab algn="l" pos="0"/>
+                        </a:tabLst>
+                      </a:pPr>
+                      <a:r>
+                        <a:rPr b="1" lang="en-US" sz="3200" spc="-1" strike="noStrike">
+                          <a:solidFill>
+                            <a:srgbClr val="ffffff"/>
+                          </a:solidFill>
+                          <a:latin typeface="Lato"/>
+                          <a:ea typeface="Lato"/>
+                        </a:rPr>
+                        <a:t>3</a:t>
+                      </a:r>
+                      <a:endParaRPr b="0" lang="en-US" sz="3200" spc="-1" strike="noStrike">
+                        <a:solidFill>
+                          <a:srgbClr val="ffffff"/>
+                        </a:solidFill>
+                        <a:latin typeface="Arial"/>
+                      </a:endParaRPr>
+                    </a:p>
+                  </a:txBody>
+                  <a:tcPr anchor="ctr" marL="190440" marR="190440">
+                    <a:lnL w="38160">
+                      <a:solidFill>
+                        <a:srgbClr val="000000"/>
+                      </a:solidFill>
+                      <a:prstDash val="solid"/>
+                    </a:lnL>
+                    <a:lnR w="38160">
+                      <a:solidFill>
+                        <a:srgbClr val="000000"/>
+                      </a:solidFill>
+                      <a:prstDash val="solid"/>
+                    </a:lnR>
+                    <a:lnT w="38160">
+                      <a:solidFill>
+                        <a:srgbClr val="000000"/>
+                      </a:solidFill>
+                      <a:prstDash val="solid"/>
+                    </a:lnT>
+                    <a:lnB w="38160">
+                      <a:solidFill>
+                        <a:srgbClr val="000000"/>
+                      </a:solidFill>
+                      <a:prstDash val="solid"/>
+                    </a:lnB>
+                    <a:solidFill>
+                      <a:srgbClr val="0e8cfe"/>
+                    </a:solidFill>
+                  </a:tcPr>
+                </a:tc>
+              </a:tr>
+              <a:tr h="1071720">
+                <a:tc>
+                  <a:txBody>
+                    <a:bodyPr lIns="190440" rIns="190440" anchor="ctr">
+                      <a:noAutofit/>
+                    </a:bodyPr>
+                    <a:p>
+                      <a:pPr algn="ctr">
+                        <a:lnSpc>
+                          <a:spcPct val="140000"/>
+                        </a:lnSpc>
+                        <a:tabLst>
+                          <a:tab algn="l" pos="0"/>
+                        </a:tabLst>
+                      </a:pPr>
+                      <a:r>
+                        <a:rPr b="1" lang="en-US" sz="3200" spc="-1" strike="noStrike">
+                          <a:solidFill>
+                            <a:srgbClr val="000000"/>
+                          </a:solidFill>
+                          <a:latin typeface="Lato"/>
+                          <a:ea typeface="Lato"/>
+                        </a:rPr>
+                        <a:t>Слогораздел</a:t>
+                      </a:r>
+                      <a:endParaRPr b="0" lang="en-US" sz="3200" spc="-1" strike="noStrike">
+                        <a:solidFill>
+                          <a:srgbClr val="000000"/>
+                        </a:solidFill>
+                        <a:latin typeface="Arial"/>
+                      </a:endParaRPr>
+                    </a:p>
+                  </a:txBody>
+                  <a:tcPr anchor="ctr" marL="190440" marR="190440">
+                    <a:lnL w="38160">
+                      <a:solidFill>
+                        <a:srgbClr val="000000"/>
+                      </a:solidFill>
+                      <a:prstDash val="solid"/>
+                    </a:lnL>
+                    <a:lnR w="38160">
+                      <a:solidFill>
+                        <a:srgbClr val="000000"/>
+                      </a:solidFill>
+                      <a:prstDash val="solid"/>
+                    </a:lnR>
+                    <a:lnT w="38160">
+                      <a:solidFill>
+                        <a:srgbClr val="000000"/>
+                      </a:solidFill>
+                      <a:prstDash val="solid"/>
+                    </a:lnT>
+                    <a:lnB w="38160">
+                      <a:solidFill>
+                        <a:srgbClr val="000000"/>
+                      </a:solidFill>
+                      <a:prstDash val="solid"/>
+                    </a:lnB>
+                    <a:solidFill>
+                      <a:srgbClr val="ffffff"/>
+                    </a:solidFill>
+                  </a:tcPr>
+                </a:tc>
+              </a:tr>
+              <a:tr h="5947560">
+                <a:tc>
+                  <a:txBody>
+                    <a:bodyPr lIns="190440" rIns="190440" anchor="ctr">
+                      <a:noAutofit/>
+                    </a:bodyPr>
+                    <a:p>
+                      <a:endParaRPr b="0" lang="en-US" sz="1800" spc="-1" strike="noStrike">
+                        <a:solidFill>
+                          <a:srgbClr val="000000"/>
+                        </a:solidFill>
+                        <a:latin typeface="Arial"/>
+                      </a:endParaRPr>
+                    </a:p>
+                  </a:txBody>
+                  <a:tcPr anchor="ctr" marL="190440" marR="190440">
+                    <a:lnL w="38160">
+                      <a:solidFill>
+                        <a:srgbClr val="000000"/>
+                      </a:solidFill>
+                      <a:prstDash val="solid"/>
+                    </a:lnL>
+                    <a:lnR w="38160">
+                      <a:solidFill>
+                        <a:srgbClr val="000000"/>
+                      </a:solidFill>
+                      <a:prstDash val="solid"/>
+                    </a:lnR>
+                    <a:lnT w="38160">
+                      <a:solidFill>
+                        <a:srgbClr val="000000"/>
+                      </a:solidFill>
+                      <a:prstDash val="solid"/>
+                    </a:lnT>
+                    <a:lnB w="38160">
+                      <a:solidFill>
+                        <a:srgbClr val="000000"/>
+                      </a:solidFill>
+                      <a:prstDash val="solid"/>
+                    </a:lnB>
+                    <a:solidFill>
+                      <a:srgbClr val="ffffff"/>
+                    </a:solidFill>
+                  </a:tcPr>
+                </a:tc>
+              </a:tr>
+            </a:tbl>
+          </a:graphicData>
+        </a:graphic>
+      </p:graphicFrame>
+      <p:graphicFrame>
+        <p:nvGraphicFramePr>
+          <p:cNvPr id="338" name="Google Shape;440;p24"/>
+          <p:cNvGraphicFramePr/>
+          <p:nvPr/>
+        </p:nvGraphicFramePr>
+        <p:xfrm>
+          <a:off x="13792320" y="1262160"/>
+          <a:ext cx="3893400" cy="8091000"/>
+        </p:xfrm>
+        <a:graphic>
+          <a:graphicData uri="http://schemas.openxmlformats.org/drawingml/2006/table">
+            <a:tbl>
+              <a:tblPr/>
+              <a:tblGrid>
+                <a:gridCol w="3893760"/>
+              </a:tblGrid>
+              <a:tr h="1071720">
+                <a:tc>
+                  <a:txBody>
+                    <a:bodyPr lIns="190440" rIns="190440" anchor="ctr">
+                      <a:noAutofit/>
+                    </a:bodyPr>
+                    <a:p>
+                      <a:pPr algn="ctr">
+                        <a:lnSpc>
+                          <a:spcPct val="140000"/>
+                        </a:lnSpc>
+                        <a:tabLst>
+                          <a:tab algn="l" pos="0"/>
+                        </a:tabLst>
+                      </a:pPr>
+                      <a:r>
+                        <a:rPr b="1" lang="en-US" sz="3200" spc="-1" strike="noStrike">
+                          <a:solidFill>
+                            <a:srgbClr val="ffffff"/>
+                          </a:solidFill>
+                          <a:latin typeface="Lato"/>
+                          <a:ea typeface="Lato"/>
+                        </a:rPr>
+                        <a:t>4</a:t>
+                      </a:r>
+                      <a:endParaRPr b="0" lang="en-US" sz="3200" spc="-1" strike="noStrike">
+                        <a:solidFill>
+                          <a:srgbClr val="000000"/>
+                        </a:solidFill>
+                        <a:latin typeface="Arial"/>
+                      </a:endParaRPr>
+                    </a:p>
+                  </a:txBody>
+                  <a:tcPr anchor="ctr" marL="190440" marR="190440">
+                    <a:lnL w="38160">
+                      <a:solidFill>
+                        <a:srgbClr val="000000"/>
+                      </a:solidFill>
+                      <a:prstDash val="solid"/>
+                    </a:lnL>
+                    <a:lnR w="38160">
+                      <a:solidFill>
+                        <a:srgbClr val="000000"/>
+                      </a:solidFill>
+                      <a:prstDash val="solid"/>
+                    </a:lnR>
+                    <a:lnT w="38160">
+                      <a:solidFill>
+                        <a:srgbClr val="000000"/>
+                      </a:solidFill>
+                      <a:prstDash val="solid"/>
+                    </a:lnT>
+                    <a:lnB w="38160">
+                      <a:solidFill>
+                        <a:srgbClr val="000000"/>
+                      </a:solidFill>
+                      <a:prstDash val="solid"/>
+                    </a:lnB>
+                    <a:solidFill>
+                      <a:srgbClr val="ffc418"/>
+                    </a:solidFill>
+                  </a:tcPr>
+                </a:tc>
+              </a:tr>
+              <a:tr h="1071720">
+                <a:tc>
+                  <a:txBody>
+                    <a:bodyPr lIns="190440" rIns="190440" anchor="ctr">
+                      <a:noAutofit/>
+                    </a:bodyPr>
+                    <a:p>
+                      <a:pPr algn="ctr">
+                        <a:lnSpc>
+                          <a:spcPct val="140000"/>
+                        </a:lnSpc>
+                        <a:tabLst>
+                          <a:tab algn="l" pos="0"/>
+                        </a:tabLst>
+                      </a:pPr>
+                      <a:r>
+                        <a:rPr b="1" lang="en-US" sz="3200" spc="-1" strike="noStrike">
+                          <a:solidFill>
+                            <a:srgbClr val="000000"/>
+                          </a:solidFill>
+                          <a:latin typeface="Lato"/>
+                          <a:ea typeface="Lato"/>
+                        </a:rPr>
+                        <a:t>Векторизация</a:t>
+                      </a:r>
+                      <a:endParaRPr b="0" lang="en-US" sz="3200" spc="-1" strike="noStrike">
+                        <a:solidFill>
+                          <a:srgbClr val="000000"/>
+                        </a:solidFill>
+                        <a:latin typeface="Arial"/>
+                      </a:endParaRPr>
+                    </a:p>
+                  </a:txBody>
+                  <a:tcPr anchor="ctr" marL="190440" marR="190440">
+                    <a:lnL w="38160">
+                      <a:solidFill>
+                        <a:srgbClr val="000000"/>
+                      </a:solidFill>
+                      <a:prstDash val="solid"/>
+                    </a:lnL>
+                    <a:lnR w="38160">
+                      <a:solidFill>
+                        <a:srgbClr val="000000"/>
+                      </a:solidFill>
+                      <a:prstDash val="solid"/>
+                    </a:lnR>
+                    <a:lnT w="38160">
+                      <a:solidFill>
+                        <a:srgbClr val="000000"/>
+                      </a:solidFill>
+                      <a:prstDash val="solid"/>
+                    </a:lnT>
+                    <a:lnB w="38160">
+                      <a:solidFill>
+                        <a:srgbClr val="000000"/>
+                      </a:solidFill>
+                      <a:prstDash val="solid"/>
+                    </a:lnB>
+                    <a:solidFill>
+                      <a:srgbClr val="ffffff"/>
+                    </a:solidFill>
+                  </a:tcPr>
+                </a:tc>
+              </a:tr>
+              <a:tr h="5947560">
+                <a:tc>
+                  <a:txBody>
+                    <a:bodyPr lIns="190440" rIns="190440" anchor="ctr">
+                      <a:noAutofit/>
+                    </a:bodyPr>
+                    <a:p>
+                      <a:endParaRPr b="0" lang="en-US" sz="1800" spc="-1" strike="noStrike">
+                        <a:solidFill>
+                          <a:srgbClr val="000000"/>
+                        </a:solidFill>
+                        <a:latin typeface="Arial"/>
+                      </a:endParaRPr>
+                    </a:p>
+                  </a:txBody>
+                  <a:tcPr anchor="ctr" marL="190440" marR="190440">
+                    <a:lnL w="38160">
+                      <a:solidFill>
+                        <a:srgbClr val="000000"/>
+                      </a:solidFill>
+                      <a:prstDash val="solid"/>
+                    </a:lnL>
+                    <a:lnR w="38160">
+                      <a:solidFill>
+                        <a:srgbClr val="000000"/>
+                      </a:solidFill>
+                      <a:prstDash val="solid"/>
+                    </a:lnR>
+                    <a:lnT w="38160">
+                      <a:solidFill>
+                        <a:srgbClr val="000000"/>
+                      </a:solidFill>
+                      <a:prstDash val="solid"/>
+                    </a:lnT>
+                    <a:lnB w="38160">
+                      <a:solidFill>
+                        <a:srgbClr val="000000"/>
+                      </a:solidFill>
+                      <a:prstDash val="solid"/>
+                    </a:lnB>
+                    <a:solidFill>
+                      <a:srgbClr val="ffffff"/>
+                    </a:solidFill>
+                  </a:tcPr>
+                </a:tc>
+              </a:tr>
+            </a:tbl>
+          </a:graphicData>
+        </a:graphic>
+      </p:graphicFrame>
+      <p:sp>
+        <p:nvSpPr>
+          <p:cNvPr id="339" name="Google Shape;441;p24"/>
+          <p:cNvSpPr/>
+          <p:nvPr/>
+        </p:nvSpPr>
+        <p:spPr>
+          <a:xfrm>
+            <a:off x="601560" y="3542400"/>
+            <a:ext cx="3684240" cy="1406880"/>
+          </a:xfrm>
+          <a:prstGeom prst="rect">
+            <a:avLst/>
+          </a:prstGeom>
+          <a:noFill/>
+          <a:ln w="0">
+            <a:noFill/>
+          </a:ln>
+        </p:spPr>
+        <p:style>
+          <a:lnRef idx="0"/>
+          <a:fillRef idx="0"/>
+          <a:effectRef idx="0"/>
+          <a:fontRef idx="minor"/>
+        </p:style>
+        <p:txBody>
+          <a:bodyPr lIns="0" rIns="0" tIns="0" bIns="0" anchor="t">
+            <a:spAutoFit/>
+          </a:bodyPr>
+          <a:p>
+            <a:pPr>
+              <a:lnSpc>
+                <a:spcPct val="140000"/>
+              </a:lnSpc>
+              <a:tabLst>
+                <a:tab algn="l" pos="0"/>
+              </a:tabLst>
+            </a:pPr>
+            <a:r>
+              <a:rPr b="0" lang="en-US" sz="2200" spc="-1" strike="noStrike">
+                <a:solidFill>
+                  <a:srgbClr val="000000"/>
+                </a:solidFill>
+                <a:latin typeface="Lato"/>
+                <a:ea typeface="Lato"/>
+              </a:rPr>
+              <a:t>Текст делим на строки, слова и знаки — базовые единицы анализа.</a:t>
+            </a:r>
+            <a:endParaRPr b="0" lang="en-US" sz="2200" spc="-1" strike="noStrike">
+              <a:solidFill>
+                <a:srgbClr val="ffffff"/>
+              </a:solidFill>
+              <a:latin typeface="Arial"/>
+            </a:endParaRPr>
+          </a:p>
+        </p:txBody>
+      </p:sp>
+      <p:sp>
+        <p:nvSpPr>
+          <p:cNvPr id="340" name="Google Shape;442;p24"/>
+          <p:cNvSpPr/>
+          <p:nvPr/>
+        </p:nvSpPr>
+        <p:spPr>
+          <a:xfrm>
+            <a:off x="5134320" y="3542400"/>
+            <a:ext cx="3573000" cy="1875960"/>
+          </a:xfrm>
+          <a:prstGeom prst="rect">
+            <a:avLst/>
+          </a:prstGeom>
+          <a:noFill/>
+          <a:ln w="0">
+            <a:noFill/>
+          </a:ln>
+        </p:spPr>
+        <p:style>
+          <a:lnRef idx="0"/>
+          <a:fillRef idx="0"/>
+          <a:effectRef idx="0"/>
+          <a:fontRef idx="minor"/>
+        </p:style>
+        <p:txBody>
+          <a:bodyPr lIns="0" rIns="0" tIns="0" bIns="0" anchor="t">
+            <a:spAutoFit/>
+          </a:bodyPr>
+          <a:p>
+            <a:pPr>
+              <a:lnSpc>
+                <a:spcPct val="140000"/>
+              </a:lnSpc>
+              <a:tabLst>
+                <a:tab algn="l" pos="0"/>
+              </a:tabLst>
+            </a:pPr>
+            <a:r>
+              <a:rPr b="0" lang="en-US" sz="2200" spc="-1" strike="noStrike">
+                <a:solidFill>
+                  <a:srgbClr val="000000"/>
+                </a:solidFill>
+                <a:latin typeface="Lato"/>
+                <a:ea typeface="Lato"/>
+              </a:rPr>
+              <a:t>Нижний регистр, чистка пунктуации; исходный вид сохраняем для показа.</a:t>
+            </a:r>
+            <a:endParaRPr b="0" lang="en-US" sz="2200" spc="-1" strike="noStrike">
+              <a:solidFill>
+                <a:srgbClr val="ffffff"/>
+              </a:solidFill>
+              <a:latin typeface="Arial"/>
+            </a:endParaRPr>
+          </a:p>
+        </p:txBody>
+      </p:sp>
+      <p:sp>
+        <p:nvSpPr>
+          <p:cNvPr id="341" name="Google Shape;443;p24"/>
+          <p:cNvSpPr/>
+          <p:nvPr/>
+        </p:nvSpPr>
+        <p:spPr>
+          <a:xfrm>
+            <a:off x="9614880" y="3542400"/>
+            <a:ext cx="3522240" cy="1875960"/>
+          </a:xfrm>
+          <a:prstGeom prst="rect">
+            <a:avLst/>
+          </a:prstGeom>
+          <a:noFill/>
+          <a:ln w="0">
+            <a:noFill/>
+          </a:ln>
+        </p:spPr>
+        <p:style>
+          <a:lnRef idx="0"/>
+          <a:fillRef idx="0"/>
+          <a:effectRef idx="0"/>
+          <a:fontRef idx="minor"/>
+        </p:style>
+        <p:txBody>
+          <a:bodyPr lIns="0" rIns="0" tIns="0" bIns="0" anchor="t">
+            <a:spAutoFit/>
+          </a:bodyPr>
+          <a:p>
+            <a:pPr>
+              <a:lnSpc>
+                <a:spcPct val="140000"/>
+              </a:lnSpc>
+              <a:tabLst>
+                <a:tab algn="l" pos="0"/>
+              </a:tabLst>
+            </a:pPr>
+            <a:r>
+              <a:rPr b="0" lang="en-US" sz="2200" spc="-1" strike="noStrike">
+                <a:solidFill>
+                  <a:srgbClr val="000000"/>
+                </a:solidFill>
+                <a:latin typeface="Lato"/>
+                <a:ea typeface="Lato"/>
+              </a:rPr>
+              <a:t>Слова разбиваем на слоги — базовую единицу рифмы и созвучия.</a:t>
+            </a:r>
+            <a:endParaRPr b="0" lang="en-US" sz="2200" spc="-1" strike="noStrike">
+              <a:solidFill>
+                <a:srgbClr val="ffffff"/>
+              </a:solidFill>
+              <a:latin typeface="Arial"/>
+            </a:endParaRPr>
+          </a:p>
+        </p:txBody>
+      </p:sp>
+      <p:sp>
+        <p:nvSpPr>
+          <p:cNvPr id="342" name="Google Shape;444;p24"/>
+          <p:cNvSpPr/>
+          <p:nvPr/>
+        </p:nvSpPr>
+        <p:spPr>
+          <a:xfrm>
+            <a:off x="14085000" y="3542400"/>
+            <a:ext cx="3517560" cy="1875960"/>
+          </a:xfrm>
+          <a:prstGeom prst="rect">
+            <a:avLst/>
+          </a:prstGeom>
+          <a:noFill/>
+          <a:ln w="0">
+            <a:noFill/>
+          </a:ln>
+        </p:spPr>
+        <p:style>
+          <a:lnRef idx="0"/>
+          <a:fillRef idx="0"/>
+          <a:effectRef idx="0"/>
+          <a:fontRef idx="minor"/>
+        </p:style>
+        <p:txBody>
+          <a:bodyPr lIns="0" rIns="0" tIns="0" bIns="0" anchor="t">
+            <a:spAutoFit/>
+          </a:bodyPr>
+          <a:p>
+            <a:pPr>
+              <a:lnSpc>
+                <a:spcPct val="140000"/>
+              </a:lnSpc>
+              <a:tabLst>
+                <a:tab algn="l" pos="0"/>
+              </a:tabLst>
+            </a:pPr>
+            <a:r>
+              <a:rPr b="0" lang="en-US" sz="2200" spc="-1" strike="noStrike">
+                <a:solidFill>
+                  <a:srgbClr val="000000"/>
+                </a:solidFill>
+                <a:latin typeface="Lato"/>
+                <a:ea typeface="Lato"/>
+              </a:rPr>
+              <a:t>Как в NLP (Word2Vec, FastText, BERT), но слог → вектор фонетических признаков.</a:t>
+            </a:r>
+            <a:endParaRPr b="0" lang="en-US" sz="2200" spc="-1" strike="noStrike">
+              <a:solidFill>
+                <a:srgbClr val="ffffff"/>
+              </a:solidFill>
+              <a:latin typeface="Arial"/>
+            </a:endParaRPr>
+          </a:p>
+        </p:txBody>
+      </p:sp>
+      <p:grpSp>
+        <p:nvGrpSpPr>
+          <p:cNvPr id="343" name="Google Shape;445;p24"/>
+          <p:cNvGrpSpPr/>
+          <p:nvPr/>
+        </p:nvGrpSpPr>
+        <p:grpSpPr>
+          <a:xfrm>
+            <a:off x="2079000" y="8849520"/>
+            <a:ext cx="729720" cy="772920"/>
+            <a:chOff x="2079000" y="8849520"/>
+            <a:chExt cx="729720" cy="772920"/>
+          </a:xfrm>
+        </p:grpSpPr>
+        <p:sp>
+          <p:nvSpPr>
+            <p:cNvPr id="344" name="Google Shape;446;p24"/>
+            <p:cNvSpPr/>
+            <p:nvPr/>
+          </p:nvSpPr>
+          <p:spPr>
+            <a:xfrm>
+              <a:off x="2079000" y="8892720"/>
+              <a:ext cx="729720" cy="729720"/>
+            </a:xfrm>
+            <a:custGeom>
+              <a:avLst/>
+              <a:gdLst>
+                <a:gd name="textAreaLeft" fmla="*/ 0 w 729720"/>
+                <a:gd name="textAreaRight" fmla="*/ 731520 w 729720"/>
+                <a:gd name="textAreaTop" fmla="*/ 0 h 729720"/>
+                <a:gd name="textAreaBottom" fmla="*/ 731520 h 729720"/>
+              </a:gdLst>
+              <a:ahLst/>
+              <a:rect l="textAreaLeft" t="textAreaTop" r="textAreaRight" b="textAreaBottom"/>
+              <a:pathLst>
+                <a:path w="812800" h="812800">
+                  <a:moveTo>
+                    <a:pt x="0" y="0"/>
+                  </a:moveTo>
+                  <a:lnTo>
+                    <a:pt x="812800" y="0"/>
+                  </a:lnTo>
+                  <a:lnTo>
+                    <a:pt x="812800" y="812800"/>
+                  </a:lnTo>
+                  <a:lnTo>
+                    <a:pt x="0" y="812800"/>
+                  </a:lnTo>
+                  <a:close/>
+                </a:path>
+              </a:pathLst>
+            </a:custGeom>
+            <a:solidFill>
+              <a:srgbClr val="b35eff"/>
+            </a:solidFill>
+            <a:ln w="0">
+              <a:noFill/>
+            </a:ln>
+          </p:spPr>
+          <p:style>
+            <a:lnRef idx="0"/>
+            <a:fillRef idx="0"/>
+            <a:effectRef idx="0"/>
+            <a:fontRef idx="minor"/>
+          </p:style>
+          <p:txBody>
+            <a:bodyPr lIns="90000" rIns="90000" tIns="45000" bIns="45000" anchor="t">
+              <a:noAutofit/>
+            </a:bodyPr>
+            <a:p>
+              <a:pPr>
+                <a:lnSpc>
+                  <a:spcPct val="100000"/>
+                </a:lnSpc>
+              </a:pPr>
+              <a:endParaRPr b="0" lang="en-US" sz="1800" spc="-1" strike="noStrike">
+                <a:solidFill>
+                  <a:srgbClr val="ffffff"/>
+                </a:solidFill>
+                <a:latin typeface="Arial"/>
+              </a:endParaRPr>
+            </a:p>
+          </p:txBody>
+        </p:sp>
+        <p:sp>
+          <p:nvSpPr>
+            <p:cNvPr id="345" name="Google Shape;447;p24"/>
+            <p:cNvSpPr/>
+            <p:nvPr/>
+          </p:nvSpPr>
+          <p:spPr>
+            <a:xfrm>
+              <a:off x="2079000" y="8849520"/>
+              <a:ext cx="729720" cy="772560"/>
+            </a:xfrm>
+            <a:prstGeom prst="rect">
+              <a:avLst/>
+            </a:prstGeom>
+            <a:noFill/>
+            <a:ln w="0">
+              <a:noFill/>
+            </a:ln>
+          </p:spPr>
+          <p:style>
+            <a:lnRef idx="0"/>
+            <a:fillRef idx="0"/>
+            <a:effectRef idx="0"/>
+            <a:fontRef idx="minor"/>
+          </p:style>
+          <p:txBody>
+            <a:bodyPr lIns="50760" rIns="50760" tIns="50760" bIns="50760" anchor="ctr">
+              <a:noAutofit/>
+            </a:bodyPr>
+            <a:p>
+              <a:pPr algn="ctr">
+                <a:lnSpc>
+                  <a:spcPct val="186000"/>
+                </a:lnSpc>
+                <a:tabLst>
+                  <a:tab algn="l" pos="0"/>
+                </a:tabLst>
+              </a:pPr>
+              <a:endParaRPr b="0" lang="en-US" sz="1400" spc="-1" strike="noStrike">
+                <a:solidFill>
+                  <a:srgbClr val="ffffff"/>
+                </a:solidFill>
+                <a:latin typeface="Arial"/>
+              </a:endParaRPr>
+            </a:p>
+          </p:txBody>
+        </p:sp>
+      </p:grpSp>
+      <p:grpSp>
+        <p:nvGrpSpPr>
+          <p:cNvPr id="346" name="Google Shape;448;p24"/>
+          <p:cNvGrpSpPr/>
+          <p:nvPr/>
+        </p:nvGrpSpPr>
+        <p:grpSpPr>
+          <a:xfrm>
+            <a:off x="6545160" y="8849520"/>
+            <a:ext cx="729720" cy="772920"/>
+            <a:chOff x="6545160" y="8849520"/>
+            <a:chExt cx="729720" cy="772920"/>
+          </a:xfrm>
+        </p:grpSpPr>
+        <p:sp>
+          <p:nvSpPr>
+            <p:cNvPr id="347" name="Google Shape;449;p24"/>
+            <p:cNvSpPr/>
+            <p:nvPr/>
+          </p:nvSpPr>
+          <p:spPr>
+            <a:xfrm>
+              <a:off x="6545160" y="8892720"/>
+              <a:ext cx="729720" cy="729720"/>
+            </a:xfrm>
+            <a:custGeom>
+              <a:avLst/>
+              <a:gdLst>
+                <a:gd name="textAreaLeft" fmla="*/ 0 w 729720"/>
+                <a:gd name="textAreaRight" fmla="*/ 731520 w 729720"/>
+                <a:gd name="textAreaTop" fmla="*/ 0 h 729720"/>
+                <a:gd name="textAreaBottom" fmla="*/ 731520 h 729720"/>
+              </a:gdLst>
+              <a:ahLst/>
+              <a:rect l="textAreaLeft" t="textAreaTop" r="textAreaRight" b="textAreaBottom"/>
+              <a:pathLst>
+                <a:path w="812800" h="812800">
+                  <a:moveTo>
+                    <a:pt x="0" y="0"/>
+                  </a:moveTo>
+                  <a:lnTo>
+                    <a:pt x="812800" y="0"/>
+                  </a:lnTo>
+                  <a:lnTo>
+                    <a:pt x="812800" y="812800"/>
+                  </a:lnTo>
+                  <a:lnTo>
+                    <a:pt x="0" y="812800"/>
+                  </a:lnTo>
+                  <a:close/>
+                </a:path>
+              </a:pathLst>
+            </a:custGeom>
+            <a:solidFill>
+              <a:srgbClr val="e30350"/>
+            </a:solidFill>
+            <a:ln w="0">
+              <a:noFill/>
+            </a:ln>
+          </p:spPr>
+          <p:style>
+            <a:lnRef idx="0"/>
+            <a:fillRef idx="0"/>
+            <a:effectRef idx="0"/>
+            <a:fontRef idx="minor"/>
+          </p:style>
+          <p:txBody>
+            <a:bodyPr lIns="90000" rIns="90000" tIns="45000" bIns="45000" anchor="t">
+              <a:noAutofit/>
+            </a:bodyPr>
+            <a:p>
+              <a:pPr>
+                <a:lnSpc>
+                  <a:spcPct val="100000"/>
+                </a:lnSpc>
+              </a:pPr>
+              <a:endParaRPr b="0" lang="en-US" sz="1800" spc="-1" strike="noStrike">
+                <a:solidFill>
+                  <a:srgbClr val="ffffff"/>
+                </a:solidFill>
+                <a:latin typeface="Arial"/>
+              </a:endParaRPr>
+            </a:p>
+          </p:txBody>
+        </p:sp>
+        <p:sp>
+          <p:nvSpPr>
+            <p:cNvPr id="348" name="Google Shape;450;p24"/>
+            <p:cNvSpPr/>
+            <p:nvPr/>
+          </p:nvSpPr>
+          <p:spPr>
+            <a:xfrm>
+              <a:off x="6545160" y="8849520"/>
+              <a:ext cx="729720" cy="772560"/>
+            </a:xfrm>
+            <a:prstGeom prst="rect">
+              <a:avLst/>
+            </a:prstGeom>
+            <a:noFill/>
+            <a:ln w="0">
+              <a:noFill/>
+            </a:ln>
+          </p:spPr>
+          <p:style>
+            <a:lnRef idx="0"/>
+            <a:fillRef idx="0"/>
+            <a:effectRef idx="0"/>
+            <a:fontRef idx="minor"/>
+          </p:style>
+          <p:txBody>
+            <a:bodyPr lIns="50760" rIns="50760" tIns="50760" bIns="50760" anchor="ctr">
+              <a:noAutofit/>
+            </a:bodyPr>
+            <a:p>
+              <a:pPr algn="ctr">
+                <a:lnSpc>
+                  <a:spcPct val="186000"/>
+                </a:lnSpc>
+                <a:tabLst>
+                  <a:tab algn="l" pos="0"/>
+                </a:tabLst>
+              </a:pPr>
+              <a:endParaRPr b="0" lang="en-US" sz="1400" spc="-1" strike="noStrike">
+                <a:solidFill>
+                  <a:srgbClr val="ffffff"/>
+                </a:solidFill>
+                <a:latin typeface="Arial"/>
+              </a:endParaRPr>
+            </a:p>
+          </p:txBody>
+        </p:sp>
+      </p:grpSp>
+      <p:grpSp>
+        <p:nvGrpSpPr>
+          <p:cNvPr id="349" name="Google Shape;451;p24"/>
+          <p:cNvGrpSpPr/>
+          <p:nvPr/>
+        </p:nvGrpSpPr>
+        <p:grpSpPr>
+          <a:xfrm>
+            <a:off x="11011320" y="8849520"/>
+            <a:ext cx="729720" cy="772920"/>
+            <a:chOff x="11011320" y="8849520"/>
+            <a:chExt cx="729720" cy="772920"/>
+          </a:xfrm>
+        </p:grpSpPr>
+        <p:sp>
+          <p:nvSpPr>
+            <p:cNvPr id="350" name="Google Shape;452;p24"/>
+            <p:cNvSpPr/>
+            <p:nvPr/>
+          </p:nvSpPr>
+          <p:spPr>
+            <a:xfrm>
+              <a:off x="11011320" y="8892720"/>
+              <a:ext cx="729720" cy="729720"/>
+            </a:xfrm>
+            <a:custGeom>
+              <a:avLst/>
+              <a:gdLst>
+                <a:gd name="textAreaLeft" fmla="*/ 0 w 729720"/>
+                <a:gd name="textAreaRight" fmla="*/ 731520 w 729720"/>
+                <a:gd name="textAreaTop" fmla="*/ 0 h 729720"/>
+                <a:gd name="textAreaBottom" fmla="*/ 731520 h 729720"/>
+              </a:gdLst>
+              <a:ahLst/>
+              <a:rect l="textAreaLeft" t="textAreaTop" r="textAreaRight" b="textAreaBottom"/>
+              <a:pathLst>
+                <a:path w="812800" h="812800">
+                  <a:moveTo>
+                    <a:pt x="0" y="0"/>
+                  </a:moveTo>
+                  <a:lnTo>
+                    <a:pt x="812800" y="0"/>
+                  </a:lnTo>
+                  <a:lnTo>
+                    <a:pt x="812800" y="812800"/>
+                  </a:lnTo>
+                  <a:lnTo>
+                    <a:pt x="0" y="812800"/>
+                  </a:lnTo>
+                  <a:close/>
+                </a:path>
+              </a:pathLst>
+            </a:custGeom>
+            <a:solidFill>
+              <a:srgbClr val="0e8cfe"/>
+            </a:solidFill>
+            <a:ln w="0">
+              <a:noFill/>
+            </a:ln>
+          </p:spPr>
+          <p:style>
+            <a:lnRef idx="0"/>
+            <a:fillRef idx="0"/>
+            <a:effectRef idx="0"/>
+            <a:fontRef idx="minor"/>
+          </p:style>
+          <p:txBody>
+            <a:bodyPr lIns="90000" rIns="90000" tIns="45000" bIns="45000" anchor="t">
+              <a:noAutofit/>
+            </a:bodyPr>
+            <a:p>
+              <a:pPr>
+                <a:lnSpc>
+                  <a:spcPct val="100000"/>
+                </a:lnSpc>
+              </a:pPr>
+              <a:endParaRPr b="0" lang="en-US" sz="1800" spc="-1" strike="noStrike">
+                <a:solidFill>
+                  <a:srgbClr val="ffffff"/>
+                </a:solidFill>
+                <a:latin typeface="Arial"/>
+              </a:endParaRPr>
+            </a:p>
+          </p:txBody>
+        </p:sp>
+        <p:sp>
+          <p:nvSpPr>
+            <p:cNvPr id="351" name="Google Shape;453;p24"/>
+            <p:cNvSpPr/>
+            <p:nvPr/>
+          </p:nvSpPr>
+          <p:spPr>
+            <a:xfrm>
+              <a:off x="11011320" y="8849520"/>
+              <a:ext cx="729720" cy="772560"/>
+            </a:xfrm>
+            <a:prstGeom prst="rect">
+              <a:avLst/>
+            </a:prstGeom>
+            <a:noFill/>
+            <a:ln w="0">
+              <a:noFill/>
+            </a:ln>
+          </p:spPr>
+          <p:style>
+            <a:lnRef idx="0"/>
+            <a:fillRef idx="0"/>
+            <a:effectRef idx="0"/>
+            <a:fontRef idx="minor"/>
+          </p:style>
+          <p:txBody>
+            <a:bodyPr lIns="50760" rIns="50760" tIns="50760" bIns="50760" anchor="ctr">
+              <a:noAutofit/>
+            </a:bodyPr>
+            <a:p>
+              <a:pPr algn="ctr">
+                <a:lnSpc>
+                  <a:spcPct val="186000"/>
+                </a:lnSpc>
+                <a:tabLst>
+                  <a:tab algn="l" pos="0"/>
+                </a:tabLst>
+              </a:pPr>
+              <a:endParaRPr b="0" lang="en-US" sz="1400" spc="-1" strike="noStrike">
+                <a:solidFill>
+                  <a:srgbClr val="ffffff"/>
+                </a:solidFill>
+                <a:latin typeface="Arial"/>
+              </a:endParaRPr>
+            </a:p>
+          </p:txBody>
+        </p:sp>
+      </p:grpSp>
+      <p:grpSp>
+        <p:nvGrpSpPr>
+          <p:cNvPr id="352" name="Google Shape;454;p24"/>
+          <p:cNvGrpSpPr/>
+          <p:nvPr/>
+        </p:nvGrpSpPr>
+        <p:grpSpPr>
+          <a:xfrm>
+            <a:off x="15477480" y="8849520"/>
+            <a:ext cx="729720" cy="772920"/>
+            <a:chOff x="15477480" y="8849520"/>
+            <a:chExt cx="729720" cy="772920"/>
+          </a:xfrm>
+        </p:grpSpPr>
+        <p:sp>
+          <p:nvSpPr>
+            <p:cNvPr id="353" name="Google Shape;455;p24"/>
+            <p:cNvSpPr/>
+            <p:nvPr/>
+          </p:nvSpPr>
+          <p:spPr>
+            <a:xfrm>
+              <a:off x="15477480" y="8892720"/>
+              <a:ext cx="729720" cy="729720"/>
+            </a:xfrm>
+            <a:custGeom>
+              <a:avLst/>
+              <a:gdLst>
+                <a:gd name="textAreaLeft" fmla="*/ 0 w 729720"/>
+                <a:gd name="textAreaRight" fmla="*/ 731520 w 729720"/>
+                <a:gd name="textAreaTop" fmla="*/ 0 h 729720"/>
+                <a:gd name="textAreaBottom" fmla="*/ 731520 h 729720"/>
+              </a:gdLst>
+              <a:ahLst/>
+              <a:rect l="textAreaLeft" t="textAreaTop" r="textAreaRight" b="textAreaBottom"/>
+              <a:pathLst>
+                <a:path w="812800" h="812800">
+                  <a:moveTo>
+                    <a:pt x="0" y="0"/>
+                  </a:moveTo>
+                  <a:lnTo>
+                    <a:pt x="812800" y="0"/>
+                  </a:lnTo>
+                  <a:lnTo>
+                    <a:pt x="812800" y="812800"/>
+                  </a:lnTo>
+                  <a:lnTo>
+                    <a:pt x="0" y="812800"/>
+                  </a:lnTo>
+                  <a:close/>
+                </a:path>
+              </a:pathLst>
+            </a:custGeom>
+            <a:solidFill>
+              <a:srgbClr val="ffc418"/>
+            </a:solidFill>
+            <a:ln w="0">
+              <a:noFill/>
+            </a:ln>
+          </p:spPr>
+          <p:style>
+            <a:lnRef idx="0"/>
+            <a:fillRef idx="0"/>
+            <a:effectRef idx="0"/>
+            <a:fontRef idx="minor"/>
+          </p:style>
+          <p:txBody>
+            <a:bodyPr lIns="90000" rIns="90000" tIns="45000" bIns="45000" anchor="t">
+              <a:noAutofit/>
+            </a:bodyPr>
+            <a:p>
+              <a:pPr>
+                <a:lnSpc>
+                  <a:spcPct val="100000"/>
+                </a:lnSpc>
+              </a:pPr>
+              <a:endParaRPr b="0" lang="en-US" sz="1800" spc="-1" strike="noStrike">
+                <a:solidFill>
+                  <a:srgbClr val="000000"/>
+                </a:solidFill>
+                <a:latin typeface="Arial"/>
+              </a:endParaRPr>
+            </a:p>
+          </p:txBody>
+        </p:sp>
+        <p:sp>
+          <p:nvSpPr>
+            <p:cNvPr id="354" name="Google Shape;456;p24"/>
+            <p:cNvSpPr/>
+            <p:nvPr/>
+          </p:nvSpPr>
+          <p:spPr>
+            <a:xfrm>
+              <a:off x="15477480" y="8849520"/>
+              <a:ext cx="729720" cy="772560"/>
+            </a:xfrm>
+            <a:prstGeom prst="rect">
+              <a:avLst/>
+            </a:prstGeom>
+            <a:noFill/>
+            <a:ln w="0">
+              <a:noFill/>
+            </a:ln>
+          </p:spPr>
+          <p:style>
+            <a:lnRef idx="0"/>
+            <a:fillRef idx="0"/>
+            <a:effectRef idx="0"/>
+            <a:fontRef idx="minor"/>
+          </p:style>
+          <p:txBody>
+            <a:bodyPr lIns="50760" rIns="50760" tIns="50760" bIns="50760" anchor="ctr">
+              <a:noAutofit/>
+            </a:bodyPr>
+            <a:p>
+              <a:pPr algn="ctr">
+                <a:lnSpc>
+                  <a:spcPct val="186000"/>
+                </a:lnSpc>
+                <a:tabLst>
+                  <a:tab algn="l" pos="0"/>
+                </a:tabLst>
+              </a:pPr>
+              <a:endParaRPr b="0" lang="en-US" sz="1400" spc="-1" strike="noStrike">
+                <a:solidFill>
+                  <a:srgbClr val="ffffff"/>
+                </a:solidFill>
+                <a:latin typeface="Arial"/>
+              </a:endParaRPr>
+            </a:p>
+          </p:txBody>
+        </p:sp>
+      </p:grpSp>
+      <p:sp>
+        <p:nvSpPr>
+          <p:cNvPr id="355" name="Google Shape;371;p21"/>
+          <p:cNvSpPr/>
+          <p:nvPr/>
+        </p:nvSpPr>
+        <p:spPr>
+          <a:xfrm>
+            <a:off x="640080" y="137160"/>
+            <a:ext cx="16457760" cy="474840"/>
+          </a:xfrm>
+          <a:prstGeom prst="rect">
+            <a:avLst/>
+          </a:prstGeom>
+          <a:noFill/>
+          <a:ln w="0">
+            <a:noFill/>
+          </a:ln>
+        </p:spPr>
+        <p:style>
+          <a:lnRef idx="0"/>
+          <a:fillRef idx="0"/>
+          <a:effectRef idx="0"/>
+          <a:fontRef idx="minor"/>
+        </p:style>
+        <p:txBody>
+          <a:bodyPr lIns="0" rIns="0" tIns="0" bIns="0" anchor="t">
+            <a:spAutoFit/>
+          </a:bodyPr>
+          <a:p>
+            <a:pPr algn="ctr">
+              <a:lnSpc>
+                <a:spcPct val="120000"/>
+              </a:lnSpc>
+              <a:tabLst>
+                <a:tab algn="l" pos="0"/>
+              </a:tabLst>
+            </a:pPr>
+            <a:r>
+              <a:rPr b="0" lang="en-US" sz="2600" spc="-1" strike="noStrike">
+                <a:solidFill>
+                  <a:srgbClr val="000000"/>
+                </a:solidFill>
+                <a:latin typeface="Bungee"/>
+                <a:ea typeface="Bungee"/>
+              </a:rPr>
+              <a:t>Подготовка текста к анализу — классический этап NLP</a:t>
+            </a:r>
+            <a:endParaRPr b="0" lang="en-US" sz="2600" spc="-1" strike="noStrike">
+              <a:solidFill>
+                <a:srgbClr val="ffffff"/>
+              </a:solidFill>
+              <a:latin typeface="Arial"/>
+            </a:endParaRPr>
+          </a:p>
+        </p:txBody>
+      </p:sp>
+    </p:spTree>
+  </p:cSld>
+  <p:clrMapOvr>
+    <a:masterClrMapping/>
+  </p:clrMapOvr>
 </p:sld>
 </file>
 

</xml_diff>